<commit_message>
Remove Raspberry Pi wording from the presentation files
- Slides, notes, tables and the explanation/script documents now describe
  collection by the capture program on the laptop microphone and webcam instead
  of a Raspberry Pi. Edits are run-level, so formatting is unchanged; the 23
  slides are intact. The earlier versions remain in Git history.
- The slide 6 hyperlink pointed at the deleted Pi-era block diagram; it now
  opens the current flow animation (../../PetMind_동작_애니메이션.html).
- 발표자료/README.md notes what was changed.

Co-Authored-By: Claude Sonnet 5.5 <noreply@anthropic.com>
</commit_message>
<xml_diff>
--- a/docs/presentation/PetMind_3주차발표자료.pptx
+++ b/docs/presentation/PetMind_3주차발표자료.pptx
@@ -1787,7 +1787,7 @@
           <a:lstStyle xmlns:a="http://schemas.openxmlformats.org/drawingml/2006/main"/>
           <a:p xmlns:a="http://schemas.openxmlformats.org/drawingml/2006/main">
             <a:r>
-              <a:t>현재는 외출 기록부터 원본 확인과 귀가 요약까지 전체 흐름을 보여줄 수 있습니다. 프로그램 자동 테스트도 통과했습니다. 다만 이것이 실제 장비의 안정성이나 짖음 분석의 정확도를 뜻하지는 않습니다. 실제 Pi 연결, 놓치는 소리 개선, 실제 보호자 질문 확인이 주요 남은 작업입니다.</a:t>
+              <a:t>현재는 외출 기록부터 원본 확인과 귀가 요약까지 전체 흐름을 보여줄 수 있습니다. 프로그램 자동 테스트도 통과했습니다. 다만 이것이 실제 장비의 안정성이나 짖음 분석의 정확도를 뜻하지는 않습니다. 실제 마이크·웹캠 연결, 놓치는 소리 개선, 실제 보호자 질문 확인이 주요 남은 작업입니다.</a:t>
             </a:r>
             <a:endParaRPr/>
           </a:p>
@@ -2469,7 +2469,7 @@
           <a:lstStyle xmlns:a="http://schemas.openxmlformats.org/drawingml/2006/main"/>
           <a:p xmlns:a="http://schemas.openxmlformats.org/drawingml/2006/main">
             <a:r>
-              <a:t>밑줄 링크를 눌러 HTML 구성도를 엽니다. Pi는 소리와 영상을 수집하고, PC는 소리를 분석하고 기록을 보관합니다. 보호자는 화면에서 원본을 확인하고 의견을 남깁니다. 전체도를 본 뒤 음성 분석과 기록 검색 부분을 눌러 자세히 설명합니다.</a:t>
+              <a:t>밑줄 링크를 눌러 HTML 구성도를 엽니다. 수집 프로그램은 노트북 마이크와 웹캠으로 소리와 영상을 수집하고, 분석 프로그램은 소리를 분석하고 기록을 보관합니다. 보호자는 화면에서 원본을 확인하고 의견을 남깁니다. 전체도를 본 뒤 음성 분석과 기록 검색 부분을 눌러 자세히 설명합니다.</a:t>
             </a:r>
           </a:p>
           <a:p xmlns:a="http://schemas.openxmlformats.org/drawingml/2006/main">
@@ -2569,7 +2569,7 @@
           <a:lstStyle xmlns:a="http://schemas.openxmlformats.org/drawingml/2006/main"/>
           <a:p xmlns:a="http://schemas.openxmlformats.org/drawingml/2006/main">
             <a:r>
-              <a:t>외출 모드를 켜면 저장 동의를 받고 새 외출 기록을 만듭니다. Pi 프로그램이 이 요청을 받아 녹음과 촬영을 시작하도록 구현했습니다. 귀가 버튼을 누르면 남은 구간을 저장한 뒤 끝냅니다. 현재는 준비한 파일로 동작을 확인했고 실제 마이크와 카메라 연결 시험은 남아 있습니다.</a:t>
+              <a:t>외출 모드를 켜면 저장 동의를 받고 새 외출 기록을 만듭니다. 수집 프로그램이 이 요청을 받아 녹음과 촬영을 시작하도록 구현했습니다. 귀가 버튼을 누르면 남은 구간을 저장한 뒤 끝냅니다. 현재는 준비한 파일로 동작을 확인했고 실제 마이크와 카메라 연결 시험은 남아 있습니다.</a:t>
             </a:r>
           </a:p>
           <a:p xmlns:a="http://schemas.openxmlformats.org/drawingml/2006/main">
@@ -3475,6 +3475,10 @@
             <a:prstDash val="solid"/>
           </a:ln>
         </p:spPr>
+        <p:txBody xmlns:a="http://schemas.openxmlformats.org/drawingml/2006/main">
+          <a:bodyPr/>
+          <a:p/>
+        </p:txBody>
       </p:sp>
       <p:sp>
         <p:nvSpPr>
@@ -3665,6 +3669,10 @@
             <a:prstDash val="solid"/>
           </a:ln>
         </p:spPr>
+        <p:txBody xmlns:a="http://schemas.openxmlformats.org/drawingml/2006/main">
+          <a:bodyPr/>
+          <a:p/>
+        </p:txBody>
       </p:sp>
       <p:sp>
         <p:nvSpPr>
@@ -3788,6 +3796,10 @@
             <a:prstDash val="solid"/>
           </a:ln>
         </p:spPr>
+        <p:txBody xmlns:a="http://schemas.openxmlformats.org/drawingml/2006/main">
+          <a:bodyPr/>
+          <a:p/>
+        </p:txBody>
       </p:sp>
       <p:sp>
         <p:nvSpPr>
@@ -3911,6 +3923,10 @@
             <a:prstDash val="solid"/>
           </a:ln>
         </p:spPr>
+        <p:txBody xmlns:a="http://schemas.openxmlformats.org/drawingml/2006/main">
+          <a:bodyPr/>
+          <a:p/>
+        </p:txBody>
       </p:sp>
       <p:sp>
         <p:nvSpPr>
@@ -4034,6 +4050,10 @@
             <a:prstDash val="solid"/>
           </a:ln>
         </p:spPr>
+        <p:txBody xmlns:a="http://schemas.openxmlformats.org/drawingml/2006/main">
+          <a:bodyPr/>
+          <a:p/>
+        </p:txBody>
       </p:sp>
       <p:sp>
         <p:nvSpPr>
@@ -4211,6 +4231,10 @@
             <a:prstDash val="solid"/>
           </a:ln>
         </p:spPr>
+        <p:txBody xmlns:a="http://schemas.openxmlformats.org/drawingml/2006/main">
+          <a:bodyPr/>
+          <a:p/>
+        </p:txBody>
       </p:sp>
       <p:sp>
         <p:nvSpPr>
@@ -5381,6 +5405,10 @@
             <a:prstDash val="solid"/>
           </a:ln>
         </p:spPr>
+        <p:txBody xmlns:a="http://schemas.openxmlformats.org/drawingml/2006/main">
+          <a:bodyPr/>
+          <a:p/>
+        </p:txBody>
       </p:sp>
       <p:sp>
         <p:nvSpPr>
@@ -7510,6 +7538,10 @@
             <a:prstDash val="solid"/>
           </a:ln>
         </p:spPr>
+        <p:txBody xmlns:a="http://schemas.openxmlformats.org/drawingml/2006/main">
+          <a:bodyPr/>
+          <a:p/>
+        </p:txBody>
       </p:sp>
       <p:sp>
         <p:nvSpPr>
@@ -8618,6 +8650,10 @@
             <a:prstDash val="solid"/>
           </a:ln>
         </p:spPr>
+        <p:txBody xmlns:a="http://schemas.openxmlformats.org/drawingml/2006/main">
+          <a:bodyPr/>
+          <a:p/>
+        </p:txBody>
       </p:sp>
       <p:sp>
         <p:nvSpPr>
@@ -10747,6 +10783,10 @@
             <a:prstDash val="solid"/>
           </a:ln>
         </p:spPr>
+        <p:txBody xmlns:a="http://schemas.openxmlformats.org/drawingml/2006/main">
+          <a:bodyPr/>
+          <a:p/>
+        </p:txBody>
       </p:sp>
       <p:sp>
         <p:nvSpPr>
@@ -11854,6 +11894,10 @@
             <a:prstDash val="solid"/>
           </a:ln>
         </p:spPr>
+        <p:txBody xmlns:a="http://schemas.openxmlformats.org/drawingml/2006/main">
+          <a:bodyPr/>
+          <a:p/>
+        </p:txBody>
       </p:sp>
       <p:sp>
         <p:nvSpPr>
@@ -13221,6 +13265,10 @@
             <a:prstDash val="solid"/>
           </a:ln>
         </p:spPr>
+        <p:txBody xmlns:a="http://schemas.openxmlformats.org/drawingml/2006/main">
+          <a:bodyPr/>
+          <a:p/>
+        </p:txBody>
       </p:sp>
       <p:sp>
         <p:nvSpPr>
@@ -13457,6 +13505,10 @@
             <a:prstDash val="solid"/>
           </a:ln>
         </p:spPr>
+        <p:txBody xmlns:a="http://schemas.openxmlformats.org/drawingml/2006/main">
+          <a:bodyPr/>
+          <a:p/>
+        </p:txBody>
       </p:sp>
       <p:sp>
         <p:nvSpPr>
@@ -13566,6 +13618,10 @@
             </a:outerShdw>
           </a:effectLst>
         </p:spPr>
+        <p:txBody xmlns:a="http://schemas.openxmlformats.org/drawingml/2006/main">
+          <a:bodyPr/>
+          <a:p/>
+        </p:txBody>
       </p:sp>
       <p:sp>
         <p:nvSpPr>
@@ -13666,6 +13722,10 @@
             <a:prstDash val="solid"/>
           </a:ln>
         </p:spPr>
+        <p:txBody xmlns:a="http://schemas.openxmlformats.org/drawingml/2006/main">
+          <a:bodyPr/>
+          <a:p/>
+        </p:txBody>
       </p:sp>
       <p:sp>
         <p:nvSpPr>
@@ -13777,6 +13837,10 @@
             <a:prstDash val="solid"/>
           </a:ln>
         </p:spPr>
+        <p:txBody xmlns:a="http://schemas.openxmlformats.org/drawingml/2006/main">
+          <a:bodyPr/>
+          <a:p/>
+        </p:txBody>
       </p:sp>
       <p:sp>
         <p:nvSpPr>
@@ -13888,6 +13952,10 @@
             <a:prstDash val="solid"/>
           </a:ln>
         </p:spPr>
+        <p:txBody xmlns:a="http://schemas.openxmlformats.org/drawingml/2006/main">
+          <a:bodyPr/>
+          <a:p/>
+        </p:txBody>
       </p:sp>
       <p:sp>
         <p:nvSpPr>
@@ -13999,6 +14067,10 @@
             <a:prstDash val="solid"/>
           </a:ln>
         </p:spPr>
+        <p:txBody xmlns:a="http://schemas.openxmlformats.org/drawingml/2006/main">
+          <a:bodyPr/>
+          <a:p/>
+        </p:txBody>
       </p:sp>
       <p:sp>
         <p:nvSpPr>
@@ -14072,7 +14144,7 @@
                 <a:ea typeface="Noto Sans KR"/>
                 <a:cs typeface="Noto Sans KR"/>
               </a:rPr>
-              <a:t>  실제 Pi에서 녹음과 영상의 시각이 맞는지, 오래 켜도 동작하는지 시험</a:t>
+              <a:t>  실제 마이크·웹캠에서 녹음과 영상의 시각이 맞는지, 오래 켜도 동작하는지 시험</a:t>
             </a:r>
             <a:endParaRPr sz="1500"/>
           </a:p>
@@ -14112,6 +14184,10 @@
             <a:prstDash val="solid"/>
           </a:ln>
         </p:spPr>
+        <p:txBody xmlns:a="http://schemas.openxmlformats.org/drawingml/2006/main">
+          <a:bodyPr/>
+          <a:p/>
+        </p:txBody>
       </p:sp>
       <p:sp>
         <p:nvSpPr>
@@ -14147,6 +14223,10 @@
             <a:prstDash val="solid"/>
           </a:ln>
         </p:spPr>
+        <p:txBody xmlns:a="http://schemas.openxmlformats.org/drawingml/2006/main">
+          <a:bodyPr/>
+          <a:p/>
+        </p:txBody>
       </p:sp>
       <p:sp>
         <p:nvSpPr>
@@ -14295,6 +14375,10 @@
             <a:prstDash val="solid"/>
           </a:ln>
         </p:spPr>
+        <p:txBody xmlns:a="http://schemas.openxmlformats.org/drawingml/2006/main">
+          <a:bodyPr/>
+          <a:p/>
+        </p:txBody>
       </p:sp>
       <p:sp>
         <p:nvSpPr>
@@ -14330,6 +14414,10 @@
             <a:prstDash val="solid"/>
           </a:ln>
         </p:spPr>
+        <p:txBody xmlns:a="http://schemas.openxmlformats.org/drawingml/2006/main">
+          <a:bodyPr/>
+          <a:p/>
+        </p:txBody>
       </p:sp>
       <p:sp>
         <p:nvSpPr>
@@ -14478,6 +14566,10 @@
             <a:prstDash val="solid"/>
           </a:ln>
         </p:spPr>
+        <p:txBody xmlns:a="http://schemas.openxmlformats.org/drawingml/2006/main">
+          <a:bodyPr/>
+          <a:p/>
+        </p:txBody>
       </p:sp>
       <p:sp>
         <p:nvSpPr>
@@ -14513,6 +14605,10 @@
             <a:prstDash val="solid"/>
           </a:ln>
         </p:spPr>
+        <p:txBody xmlns:a="http://schemas.openxmlformats.org/drawingml/2006/main">
+          <a:bodyPr/>
+          <a:p/>
+        </p:txBody>
       </p:sp>
       <p:sp>
         <p:nvSpPr>
@@ -14709,6 +14805,10 @@
             <a:prstDash val="solid"/>
           </a:ln>
         </p:spPr>
+        <p:txBody xmlns:a="http://schemas.openxmlformats.org/drawingml/2006/main">
+          <a:bodyPr/>
+          <a:p/>
+        </p:txBody>
       </p:sp>
       <p:sp>
         <p:nvSpPr>
@@ -14945,6 +15045,10 @@
             <a:prstDash val="solid"/>
           </a:ln>
         </p:spPr>
+        <p:txBody xmlns:a="http://schemas.openxmlformats.org/drawingml/2006/main">
+          <a:bodyPr/>
+          <a:p/>
+        </p:txBody>
       </p:sp>
       <p:sp>
         <p:nvSpPr>
@@ -15054,6 +15158,10 @@
             </a:outerShdw>
           </a:effectLst>
         </p:spPr>
+        <p:txBody xmlns:a="http://schemas.openxmlformats.org/drawingml/2006/main">
+          <a:bodyPr/>
+          <a:p/>
+        </p:txBody>
       </p:sp>
       <p:sp>
         <p:nvSpPr>
@@ -15154,6 +15262,10 @@
             <a:prstDash val="solid"/>
           </a:ln>
         </p:spPr>
+        <p:txBody xmlns:a="http://schemas.openxmlformats.org/drawingml/2006/main">
+          <a:bodyPr/>
+          <a:p/>
+        </p:txBody>
       </p:sp>
       <p:sp>
         <p:nvSpPr>
@@ -15265,6 +15377,10 @@
             <a:prstDash val="solid"/>
           </a:ln>
         </p:spPr>
+        <p:txBody xmlns:a="http://schemas.openxmlformats.org/drawingml/2006/main">
+          <a:bodyPr/>
+          <a:p/>
+        </p:txBody>
       </p:sp>
       <p:sp>
         <p:nvSpPr>
@@ -15365,6 +15481,10 @@
             <a:prstDash val="solid"/>
           </a:ln>
         </p:spPr>
+        <p:txBody xmlns:a="http://schemas.openxmlformats.org/drawingml/2006/main">
+          <a:bodyPr/>
+          <a:p/>
+        </p:txBody>
       </p:sp>
       <p:sp>
         <p:nvSpPr>
@@ -15465,6 +15585,10 @@
             <a:prstDash val="solid"/>
           </a:ln>
         </p:spPr>
+        <p:txBody xmlns:a="http://schemas.openxmlformats.org/drawingml/2006/main">
+          <a:bodyPr/>
+          <a:p/>
+        </p:txBody>
       </p:sp>
       <p:sp>
         <p:nvSpPr>
@@ -15578,6 +15702,10 @@
             <a:prstDash val="solid"/>
           </a:ln>
         </p:spPr>
+        <p:txBody xmlns:a="http://schemas.openxmlformats.org/drawingml/2006/main">
+          <a:bodyPr/>
+          <a:p/>
+        </p:txBody>
       </p:sp>
       <p:sp>
         <p:nvSpPr>
@@ -15613,6 +15741,10 @@
             <a:prstDash val="solid"/>
           </a:ln>
         </p:spPr>
+        <p:txBody xmlns:a="http://schemas.openxmlformats.org/drawingml/2006/main">
+          <a:bodyPr/>
+          <a:p/>
+        </p:txBody>
       </p:sp>
       <p:sp>
         <p:nvSpPr>
@@ -15761,6 +15893,10 @@
             <a:prstDash val="solid"/>
           </a:ln>
         </p:spPr>
+        <p:txBody xmlns:a="http://schemas.openxmlformats.org/drawingml/2006/main">
+          <a:bodyPr/>
+          <a:p/>
+        </p:txBody>
       </p:sp>
       <p:sp>
         <p:nvSpPr>
@@ -15796,6 +15932,10 @@
             <a:prstDash val="solid"/>
           </a:ln>
         </p:spPr>
+        <p:txBody xmlns:a="http://schemas.openxmlformats.org/drawingml/2006/main">
+          <a:bodyPr/>
+          <a:p/>
+        </p:txBody>
       </p:sp>
       <p:sp>
         <p:nvSpPr>
@@ -15944,6 +16084,10 @@
             <a:prstDash val="solid"/>
           </a:ln>
         </p:spPr>
+        <p:txBody xmlns:a="http://schemas.openxmlformats.org/drawingml/2006/main">
+          <a:bodyPr/>
+          <a:p/>
+        </p:txBody>
       </p:sp>
       <p:sp>
         <p:nvSpPr>
@@ -15979,6 +16123,10 @@
             <a:prstDash val="solid"/>
           </a:ln>
         </p:spPr>
+        <p:txBody xmlns:a="http://schemas.openxmlformats.org/drawingml/2006/main">
+          <a:bodyPr/>
+          <a:p/>
+        </p:txBody>
       </p:sp>
       <p:sp>
         <p:nvSpPr>
@@ -16127,6 +16275,10 @@
             <a:prstDash val="solid"/>
           </a:ln>
         </p:spPr>
+        <p:txBody xmlns:a="http://schemas.openxmlformats.org/drawingml/2006/main">
+          <a:bodyPr/>
+          <a:p/>
+        </p:txBody>
       </p:sp>
       <p:sp>
         <p:nvSpPr>
@@ -16162,6 +16314,10 @@
             <a:prstDash val="solid"/>
           </a:ln>
         </p:spPr>
+        <p:txBody xmlns:a="http://schemas.openxmlformats.org/drawingml/2006/main">
+          <a:bodyPr/>
+          <a:p/>
+        </p:txBody>
       </p:sp>
       <p:sp>
         <p:nvSpPr>
@@ -16427,6 +16583,10 @@
             <a:prstDash val="solid"/>
           </a:ln>
         </p:spPr>
+        <p:txBody xmlns:a="http://schemas.openxmlformats.org/drawingml/2006/main">
+          <a:bodyPr/>
+          <a:p/>
+        </p:txBody>
       </p:sp>
       <p:sp>
         <p:nvSpPr>
@@ -16663,6 +16823,10 @@
             <a:prstDash val="solid"/>
           </a:ln>
         </p:spPr>
+        <p:txBody xmlns:a="http://schemas.openxmlformats.org/drawingml/2006/main">
+          <a:bodyPr/>
+          <a:p/>
+        </p:txBody>
       </p:sp>
       <p:sp>
         <p:nvSpPr>
@@ -16772,6 +16936,10 @@
             </a:outerShdw>
           </a:effectLst>
         </p:spPr>
+        <p:txBody xmlns:a="http://schemas.openxmlformats.org/drawingml/2006/main">
+          <a:bodyPr/>
+          <a:p/>
+        </p:txBody>
       </p:sp>
       <p:sp>
         <p:nvSpPr>
@@ -16872,6 +17040,10 @@
             <a:prstDash val="solid"/>
           </a:ln>
         </p:spPr>
+        <p:txBody xmlns:a="http://schemas.openxmlformats.org/drawingml/2006/main">
+          <a:bodyPr/>
+          <a:p/>
+        </p:txBody>
       </p:sp>
       <p:sp>
         <p:nvSpPr>
@@ -16983,6 +17155,10 @@
             <a:prstDash val="solid"/>
           </a:ln>
         </p:spPr>
+        <p:txBody xmlns:a="http://schemas.openxmlformats.org/drawingml/2006/main">
+          <a:bodyPr/>
+          <a:p/>
+        </p:txBody>
       </p:sp>
       <p:sp>
         <p:nvSpPr>
@@ -17094,6 +17270,10 @@
             <a:prstDash val="solid"/>
           </a:ln>
         </p:spPr>
+        <p:txBody xmlns:a="http://schemas.openxmlformats.org/drawingml/2006/main">
+          <a:bodyPr/>
+          <a:p/>
+        </p:txBody>
       </p:sp>
       <p:sp>
         <p:nvSpPr>
@@ -17205,6 +17385,10 @@
             <a:prstDash val="solid"/>
           </a:ln>
         </p:spPr>
+        <p:txBody xmlns:a="http://schemas.openxmlformats.org/drawingml/2006/main">
+          <a:bodyPr/>
+          <a:p/>
+        </p:txBody>
       </p:sp>
       <p:sp>
         <p:nvSpPr>
@@ -17318,6 +17502,10 @@
             <a:prstDash val="solid"/>
           </a:ln>
         </p:spPr>
+        <p:txBody xmlns:a="http://schemas.openxmlformats.org/drawingml/2006/main">
+          <a:bodyPr/>
+          <a:p/>
+        </p:txBody>
       </p:sp>
       <p:sp>
         <p:nvSpPr>
@@ -17353,6 +17541,10 @@
             <a:prstDash val="solid"/>
           </a:ln>
         </p:spPr>
+        <p:txBody xmlns:a="http://schemas.openxmlformats.org/drawingml/2006/main">
+          <a:bodyPr/>
+          <a:p/>
+        </p:txBody>
       </p:sp>
       <p:sp>
         <p:nvSpPr>
@@ -17501,6 +17693,10 @@
             <a:prstDash val="solid"/>
           </a:ln>
         </p:spPr>
+        <p:txBody xmlns:a="http://schemas.openxmlformats.org/drawingml/2006/main">
+          <a:bodyPr/>
+          <a:p/>
+        </p:txBody>
       </p:sp>
       <p:sp>
         <p:nvSpPr>
@@ -17536,6 +17732,10 @@
             <a:prstDash val="solid"/>
           </a:ln>
         </p:spPr>
+        <p:txBody xmlns:a="http://schemas.openxmlformats.org/drawingml/2006/main">
+          <a:bodyPr/>
+          <a:p/>
+        </p:txBody>
       </p:sp>
       <p:sp>
         <p:nvSpPr>
@@ -17684,6 +17884,10 @@
             <a:prstDash val="solid"/>
           </a:ln>
         </p:spPr>
+        <p:txBody xmlns:a="http://schemas.openxmlformats.org/drawingml/2006/main">
+          <a:bodyPr/>
+          <a:p/>
+        </p:txBody>
       </p:sp>
       <p:sp>
         <p:nvSpPr>
@@ -17719,6 +17923,10 @@
             <a:prstDash val="solid"/>
           </a:ln>
         </p:spPr>
+        <p:txBody xmlns:a="http://schemas.openxmlformats.org/drawingml/2006/main">
+          <a:bodyPr/>
+          <a:p/>
+        </p:txBody>
       </p:sp>
       <p:sp>
         <p:nvSpPr>
@@ -17915,6 +18123,10 @@
             <a:prstDash val="solid"/>
           </a:ln>
         </p:spPr>
+        <p:txBody xmlns:a="http://schemas.openxmlformats.org/drawingml/2006/main">
+          <a:bodyPr/>
+          <a:p/>
+        </p:txBody>
       </p:sp>
       <p:sp>
         <p:nvSpPr>
@@ -18972,6 +19184,10 @@
             </a:outerShdw>
           </a:effectLst>
         </p:spPr>
+        <p:txBody xmlns:a="http://schemas.openxmlformats.org/drawingml/2006/main">
+          <a:bodyPr/>
+          <a:p/>
+        </p:txBody>
       </p:sp>
       <p:sp>
         <p:nvSpPr>
@@ -19194,6 +19410,10 @@
             </a:outerShdw>
           </a:effectLst>
         </p:spPr>
+        <p:txBody xmlns:a="http://schemas.openxmlformats.org/drawingml/2006/main">
+          <a:bodyPr/>
+          <a:p/>
+        </p:txBody>
       </p:sp>
       <p:sp>
         <p:nvSpPr>
@@ -19416,6 +19636,10 @@
             </a:outerShdw>
           </a:effectLst>
         </p:spPr>
+        <p:txBody xmlns:a="http://schemas.openxmlformats.org/drawingml/2006/main">
+          <a:bodyPr/>
+          <a:p/>
+        </p:txBody>
       </p:sp>
       <p:sp>
         <p:nvSpPr>
@@ -19638,6 +19862,10 @@
             </a:outerShdw>
           </a:effectLst>
         </p:spPr>
+        <p:txBody xmlns:a="http://schemas.openxmlformats.org/drawingml/2006/main">
+          <a:bodyPr/>
+          <a:p/>
+        </p:txBody>
       </p:sp>
       <p:sp>
         <p:nvSpPr>
@@ -19860,6 +20088,10 @@
             </a:outerShdw>
           </a:effectLst>
         </p:spPr>
+        <p:txBody xmlns:a="http://schemas.openxmlformats.org/drawingml/2006/main">
+          <a:bodyPr/>
+          <a:p/>
+        </p:txBody>
       </p:sp>
       <p:sp>
         <p:nvSpPr>
@@ -20169,6 +20401,10 @@
             <a:prstDash val="solid"/>
           </a:ln>
         </p:spPr>
+        <p:txBody xmlns:a="http://schemas.openxmlformats.org/drawingml/2006/main">
+          <a:bodyPr/>
+          <a:p/>
+        </p:txBody>
       </p:sp>
       <p:sp>
         <p:nvSpPr>
@@ -20718,7 +20954,7 @@
                           <a:ea typeface="Noto Sans KR"/>
                           <a:cs typeface="Noto Sans KR"/>
                         </a:rPr>
-                        <a:t>실제 Pi로 처음부터 끝까지 시연</a:t>
+                        <a:t>실제 마이크·웹캠으로 처음부터 끝까지 시연</a:t>
                       </a:r>
                     </a:p>
                   </a:txBody>
@@ -21470,6 +21706,10 @@
             <a:prstDash val="solid"/>
           </a:ln>
         </p:spPr>
+        <p:txBody xmlns:a="http://schemas.openxmlformats.org/drawingml/2006/main">
+          <a:bodyPr/>
+          <a:p/>
+        </p:txBody>
       </p:sp>
       <p:sp>
         <p:nvSpPr>
@@ -22407,6 +22647,10 @@
             <a:prstDash val="solid"/>
           </a:ln>
         </p:spPr>
+        <p:txBody xmlns:a="http://schemas.openxmlformats.org/drawingml/2006/main">
+          <a:bodyPr/>
+          <a:p/>
+        </p:txBody>
       </p:sp>
       <p:sp>
         <p:nvSpPr>
@@ -22618,6 +22862,10 @@
             <a:prstDash val="solid"/>
           </a:ln>
         </p:spPr>
+        <p:txBody xmlns:a="http://schemas.openxmlformats.org/drawingml/2006/main">
+          <a:bodyPr/>
+          <a:p/>
+        </p:txBody>
       </p:sp>
       <p:sp>
         <p:nvSpPr>
@@ -22651,6 +22899,10 @@
             <a:prstDash val="solid"/>
           </a:ln>
         </p:spPr>
+        <p:txBody xmlns:a="http://schemas.openxmlformats.org/drawingml/2006/main">
+          <a:bodyPr/>
+          <a:p/>
+        </p:txBody>
       </p:sp>
       <p:sp>
         <p:nvSpPr>
@@ -22693,6 +22945,10 @@
             </a:outerShdw>
           </a:effectLst>
         </p:spPr>
+        <p:txBody xmlns:a="http://schemas.openxmlformats.org/drawingml/2006/main">
+          <a:bodyPr/>
+          <a:p/>
+        </p:txBody>
       </p:sp>
       <p:sp>
         <p:nvSpPr>
@@ -23053,6 +23309,10 @@
             <a:prstDash val="solid"/>
           </a:ln>
         </p:spPr>
+        <p:txBody xmlns:a="http://schemas.openxmlformats.org/drawingml/2006/main">
+          <a:bodyPr/>
+          <a:p/>
+        </p:txBody>
       </p:sp>
       <p:sp>
         <p:nvSpPr>
@@ -23095,6 +23355,10 @@
             </a:outerShdw>
           </a:effectLst>
         </p:spPr>
+        <p:txBody xmlns:a="http://schemas.openxmlformats.org/drawingml/2006/main">
+          <a:bodyPr/>
+          <a:p/>
+        </p:txBody>
       </p:sp>
       <p:sp>
         <p:nvSpPr>
@@ -23413,6 +23677,10 @@
             <a:prstDash val="solid"/>
           </a:ln>
         </p:spPr>
+        <p:txBody xmlns:a="http://schemas.openxmlformats.org/drawingml/2006/main">
+          <a:bodyPr/>
+          <a:p/>
+        </p:txBody>
       </p:sp>
       <p:sp>
         <p:nvSpPr>
@@ -23455,6 +23723,10 @@
             </a:outerShdw>
           </a:effectLst>
         </p:spPr>
+        <p:txBody xmlns:a="http://schemas.openxmlformats.org/drawingml/2006/main">
+          <a:bodyPr/>
+          <a:p/>
+        </p:txBody>
       </p:sp>
       <p:sp>
         <p:nvSpPr>
@@ -23773,6 +24045,10 @@
             <a:prstDash val="solid"/>
           </a:ln>
         </p:spPr>
+        <p:txBody xmlns:a="http://schemas.openxmlformats.org/drawingml/2006/main">
+          <a:bodyPr/>
+          <a:p/>
+        </p:txBody>
       </p:sp>
       <p:sp>
         <p:nvSpPr>
@@ -23815,6 +24091,10 @@
             </a:outerShdw>
           </a:effectLst>
         </p:spPr>
+        <p:txBody xmlns:a="http://schemas.openxmlformats.org/drawingml/2006/main">
+          <a:bodyPr/>
+          <a:p/>
+        </p:txBody>
       </p:sp>
       <p:sp>
         <p:nvSpPr>
@@ -24136,6 +24416,10 @@
             <a:prstDash val="solid"/>
           </a:ln>
         </p:spPr>
+        <p:txBody xmlns:a="http://schemas.openxmlformats.org/drawingml/2006/main">
+          <a:bodyPr/>
+          <a:p/>
+        </p:txBody>
       </p:sp>
       <p:sp>
         <p:nvSpPr>
@@ -24178,6 +24462,10 @@
             </a:outerShdw>
           </a:effectLst>
         </p:spPr>
+        <p:txBody xmlns:a="http://schemas.openxmlformats.org/drawingml/2006/main">
+          <a:bodyPr/>
+          <a:p/>
+        </p:txBody>
       </p:sp>
       <p:sp>
         <p:nvSpPr>
@@ -24499,6 +24787,10 @@
             <a:prstDash val="solid"/>
           </a:ln>
         </p:spPr>
+        <p:txBody xmlns:a="http://schemas.openxmlformats.org/drawingml/2006/main">
+          <a:bodyPr/>
+          <a:p/>
+        </p:txBody>
       </p:sp>
       <p:sp>
         <p:nvSpPr>
@@ -24541,6 +24833,10 @@
             </a:outerShdw>
           </a:effectLst>
         </p:spPr>
+        <p:txBody xmlns:a="http://schemas.openxmlformats.org/drawingml/2006/main">
+          <a:bodyPr/>
+          <a:p/>
+        </p:txBody>
       </p:sp>
       <p:sp>
         <p:nvSpPr>
@@ -24864,6 +25160,10 @@
             <a:prstDash val="solid"/>
           </a:ln>
         </p:spPr>
+        <p:txBody xmlns:a="http://schemas.openxmlformats.org/drawingml/2006/main">
+          <a:bodyPr/>
+          <a:p/>
+        </p:txBody>
       </p:sp>
       <p:sp>
         <p:nvSpPr>
@@ -25215,6 +25515,10 @@
             <a:prstDash val="solid"/>
           </a:ln>
         </p:spPr>
+        <p:txBody xmlns:a="http://schemas.openxmlformats.org/drawingml/2006/main">
+          <a:bodyPr/>
+          <a:p/>
+        </p:txBody>
       </p:sp>
       <p:sp>
         <p:nvSpPr>
@@ -25338,6 +25642,10 @@
             <a:prstDash val="solid"/>
           </a:ln>
         </p:spPr>
+        <p:txBody xmlns:a="http://schemas.openxmlformats.org/drawingml/2006/main">
+          <a:bodyPr/>
+          <a:p/>
+        </p:txBody>
       </p:sp>
       <p:sp>
         <p:nvSpPr>
@@ -25461,6 +25769,10 @@
             <a:prstDash val="solid"/>
           </a:ln>
         </p:spPr>
+        <p:txBody xmlns:a="http://schemas.openxmlformats.org/drawingml/2006/main">
+          <a:bodyPr/>
+          <a:p/>
+        </p:txBody>
       </p:sp>
       <p:sp>
         <p:nvSpPr>
@@ -25659,6 +25971,10 @@
             <a:prstDash val="solid"/>
           </a:ln>
         </p:spPr>
+        <p:txBody xmlns:a="http://schemas.openxmlformats.org/drawingml/2006/main">
+          <a:bodyPr/>
+          <a:p/>
+        </p:txBody>
       </p:sp>
       <p:sp>
         <p:nvSpPr>
@@ -25874,6 +26190,10 @@
             <a:prstDash val="solid"/>
           </a:ln>
         </p:spPr>
+        <p:txBody xmlns:a="http://schemas.openxmlformats.org/drawingml/2006/main">
+          <a:bodyPr/>
+          <a:p/>
+        </p:txBody>
       </p:sp>
       <p:sp>
         <p:nvSpPr>
@@ -26075,6 +26395,10 @@
             </a:outerShdw>
           </a:effectLst>
         </p:spPr>
+        <p:txBody xmlns:a="http://schemas.openxmlformats.org/drawingml/2006/main">
+          <a:bodyPr/>
+          <a:p/>
+        </p:txBody>
       </p:sp>
       <p:sp>
         <p:nvSpPr>
@@ -26110,6 +26434,10 @@
             <a:prstDash val="solid"/>
           </a:ln>
         </p:spPr>
+        <p:txBody xmlns:a="http://schemas.openxmlformats.org/drawingml/2006/main">
+          <a:bodyPr/>
+          <a:p/>
+        </p:txBody>
       </p:sp>
       <p:sp>
         <p:nvSpPr>
@@ -26283,6 +26611,10 @@
             <a:prstDash val="solid"/>
           </a:ln>
         </p:spPr>
+        <p:txBody xmlns:a="http://schemas.openxmlformats.org/drawingml/2006/main">
+          <a:bodyPr/>
+          <a:p/>
+        </p:txBody>
       </p:sp>
       <p:sp>
         <p:nvSpPr>
@@ -26484,6 +26816,10 @@
             </a:outerShdw>
           </a:effectLst>
         </p:spPr>
+        <p:txBody xmlns:a="http://schemas.openxmlformats.org/drawingml/2006/main">
+          <a:bodyPr/>
+          <a:p/>
+        </p:txBody>
       </p:sp>
       <p:sp>
         <p:nvSpPr>
@@ -26519,6 +26855,10 @@
             <a:prstDash val="solid"/>
           </a:ln>
         </p:spPr>
+        <p:txBody xmlns:a="http://schemas.openxmlformats.org/drawingml/2006/main">
+          <a:bodyPr/>
+          <a:p/>
+        </p:txBody>
       </p:sp>
       <p:sp>
         <p:nvSpPr>
@@ -26691,6 +27031,10 @@
             <a:prstDash val="solid"/>
           </a:ln>
         </p:spPr>
+        <p:txBody xmlns:a="http://schemas.openxmlformats.org/drawingml/2006/main">
+          <a:bodyPr/>
+          <a:p/>
+        </p:txBody>
       </p:sp>
       <p:sp>
         <p:nvSpPr>
@@ -26892,6 +27236,10 @@
             </a:outerShdw>
           </a:effectLst>
         </p:spPr>
+        <p:txBody xmlns:a="http://schemas.openxmlformats.org/drawingml/2006/main">
+          <a:bodyPr/>
+          <a:p/>
+        </p:txBody>
       </p:sp>
       <p:sp>
         <p:nvSpPr>
@@ -26927,6 +27275,10 @@
             <a:prstDash val="solid"/>
           </a:ln>
         </p:spPr>
+        <p:txBody xmlns:a="http://schemas.openxmlformats.org/drawingml/2006/main">
+          <a:bodyPr/>
+          <a:p/>
+        </p:txBody>
       </p:sp>
       <p:sp>
         <p:nvSpPr>
@@ -27100,6 +27452,10 @@
             <a:prstDash val="solid"/>
           </a:ln>
         </p:spPr>
+        <p:txBody xmlns:a="http://schemas.openxmlformats.org/drawingml/2006/main">
+          <a:bodyPr/>
+          <a:p/>
+        </p:txBody>
       </p:sp>
       <p:sp>
         <p:nvSpPr>
@@ -27301,6 +27657,10 @@
             </a:outerShdw>
           </a:effectLst>
         </p:spPr>
+        <p:txBody xmlns:a="http://schemas.openxmlformats.org/drawingml/2006/main">
+          <a:bodyPr/>
+          <a:p/>
+        </p:txBody>
       </p:sp>
       <p:sp>
         <p:nvSpPr>
@@ -27336,6 +27696,10 @@
             <a:prstDash val="solid"/>
           </a:ln>
         </p:spPr>
+        <p:txBody xmlns:a="http://schemas.openxmlformats.org/drawingml/2006/main">
+          <a:bodyPr/>
+          <a:p/>
+        </p:txBody>
       </p:sp>
       <p:sp>
         <p:nvSpPr>
@@ -27672,6 +28036,10 @@
             <a:prstDash val="solid"/>
           </a:ln>
         </p:spPr>
+        <p:txBody xmlns:a="http://schemas.openxmlformats.org/drawingml/2006/main">
+          <a:bodyPr/>
+          <a:p/>
+        </p:txBody>
       </p:sp>
       <p:sp>
         <p:nvSpPr>
@@ -27887,6 +28255,10 @@
             <a:prstDash val="solid"/>
           </a:ln>
         </p:spPr>
+        <p:txBody xmlns:a="http://schemas.openxmlformats.org/drawingml/2006/main">
+          <a:bodyPr/>
+          <a:p/>
+        </p:txBody>
       </p:sp>
       <p:sp>
         <p:nvSpPr>
@@ -27929,6 +28301,10 @@
             </a:outerShdw>
           </a:effectLst>
         </p:spPr>
+        <p:txBody xmlns:a="http://schemas.openxmlformats.org/drawingml/2006/main">
+          <a:bodyPr/>
+          <a:p/>
+        </p:txBody>
       </p:sp>
       <p:sp>
         <p:nvSpPr>
@@ -28496,6 +28872,10 @@
             <a:prstDash val="solid"/>
           </a:ln>
         </p:spPr>
+        <p:txBody xmlns:a="http://schemas.openxmlformats.org/drawingml/2006/main">
+          <a:bodyPr/>
+          <a:p/>
+        </p:txBody>
       </p:sp>
       <p:sp>
         <p:nvSpPr>
@@ -28527,6 +28907,10 @@
             <a:prstDash val="solid"/>
           </a:ln>
         </p:spPr>
+        <p:txBody xmlns:a="http://schemas.openxmlformats.org/drawingml/2006/main">
+          <a:bodyPr/>
+          <a:p/>
+        </p:txBody>
       </p:sp>
       <p:sp>
         <p:nvSpPr>
@@ -28759,6 +29143,10 @@
             <a:prstDash val="solid"/>
           </a:ln>
         </p:spPr>
+        <p:txBody xmlns:a="http://schemas.openxmlformats.org/drawingml/2006/main">
+          <a:bodyPr/>
+          <a:p/>
+        </p:txBody>
       </p:sp>
       <p:sp>
         <p:nvSpPr>
@@ -28790,6 +29178,10 @@
             <a:prstDash val="solid"/>
           </a:ln>
         </p:spPr>
+        <p:txBody xmlns:a="http://schemas.openxmlformats.org/drawingml/2006/main">
+          <a:bodyPr/>
+          <a:p/>
+        </p:txBody>
       </p:sp>
       <p:sp>
         <p:nvSpPr>
@@ -29022,6 +29414,10 @@
             <a:prstDash val="solid"/>
           </a:ln>
         </p:spPr>
+        <p:txBody xmlns:a="http://schemas.openxmlformats.org/drawingml/2006/main">
+          <a:bodyPr/>
+          <a:p/>
+        </p:txBody>
       </p:sp>
       <p:sp>
         <p:nvSpPr>
@@ -29053,6 +29449,10 @@
             <a:prstDash val="solid"/>
           </a:ln>
         </p:spPr>
+        <p:txBody xmlns:a="http://schemas.openxmlformats.org/drawingml/2006/main">
+          <a:bodyPr/>
+          <a:p/>
+        </p:txBody>
       </p:sp>
       <p:sp>
         <p:nvSpPr>
@@ -29285,6 +29685,10 @@
             <a:prstDash val="solid"/>
           </a:ln>
         </p:spPr>
+        <p:txBody xmlns:a="http://schemas.openxmlformats.org/drawingml/2006/main">
+          <a:bodyPr/>
+          <a:p/>
+        </p:txBody>
       </p:sp>
       <p:sp>
         <p:nvSpPr>
@@ -29316,6 +29720,10 @@
             <a:prstDash val="solid"/>
           </a:ln>
         </p:spPr>
+        <p:txBody xmlns:a="http://schemas.openxmlformats.org/drawingml/2006/main">
+          <a:bodyPr/>
+          <a:p/>
+        </p:txBody>
       </p:sp>
       <p:sp>
         <p:nvSpPr>
@@ -29548,6 +29956,10 @@
             <a:prstDash val="solid"/>
           </a:ln>
         </p:spPr>
+        <p:txBody xmlns:a="http://schemas.openxmlformats.org/drawingml/2006/main">
+          <a:bodyPr/>
+          <a:p/>
+        </p:txBody>
       </p:sp>
       <p:sp>
         <p:nvSpPr>
@@ -29579,6 +29991,10 @@
             <a:prstDash val="solid"/>
           </a:ln>
         </p:spPr>
+        <p:txBody xmlns:a="http://schemas.openxmlformats.org/drawingml/2006/main">
+          <a:bodyPr/>
+          <a:p/>
+        </p:txBody>
       </p:sp>
       <p:sp>
         <p:nvSpPr>
@@ -29708,6 +30124,10 @@
             <a:prstDash val="solid"/>
           </a:ln>
         </p:spPr>
+        <p:txBody xmlns:a="http://schemas.openxmlformats.org/drawingml/2006/main">
+          <a:bodyPr/>
+          <a:p/>
+        </p:txBody>
       </p:sp>
       <p:sp>
         <p:nvSpPr>
@@ -29909,6 +30329,10 @@
             </a:outerShdw>
           </a:effectLst>
         </p:spPr>
+        <p:txBody xmlns:a="http://schemas.openxmlformats.org/drawingml/2006/main">
+          <a:bodyPr/>
+          <a:p/>
+        </p:txBody>
       </p:sp>
       <p:sp>
         <p:nvSpPr>
@@ -29951,6 +30375,10 @@
             </a:outerShdw>
           </a:effectLst>
         </p:spPr>
+        <p:txBody xmlns:a="http://schemas.openxmlformats.org/drawingml/2006/main">
+          <a:bodyPr/>
+          <a:p/>
+        </p:txBody>
       </p:sp>
       <p:sp>
         <p:nvSpPr>
@@ -30250,6 +30678,10 @@
             <a:prstDash val="solid"/>
           </a:ln>
         </p:spPr>
+        <p:txBody xmlns:a="http://schemas.openxmlformats.org/drawingml/2006/main">
+          <a:bodyPr/>
+          <a:p/>
+        </p:txBody>
       </p:sp>
       <p:sp>
         <p:nvSpPr>
@@ -30482,6 +30914,10 @@
             <a:prstDash val="solid"/>
           </a:ln>
         </p:spPr>
+        <p:txBody xmlns:a="http://schemas.openxmlformats.org/drawingml/2006/main">
+          <a:bodyPr/>
+          <a:p/>
+        </p:txBody>
       </p:sp>
       <p:sp>
         <p:nvSpPr>
@@ -30714,6 +31150,10 @@
             <a:prstDash val="solid"/>
           </a:ln>
         </p:spPr>
+        <p:txBody xmlns:a="http://schemas.openxmlformats.org/drawingml/2006/main">
+          <a:bodyPr/>
+          <a:p/>
+        </p:txBody>
       </p:sp>
       <p:sp>
         <p:nvSpPr>
@@ -31063,6 +31503,10 @@
             <a:prstDash val="solid"/>
           </a:ln>
         </p:spPr>
+        <p:txBody xmlns:a="http://schemas.openxmlformats.org/drawingml/2006/main">
+          <a:bodyPr/>
+          <a:p/>
+        </p:txBody>
       </p:sp>
       <p:sp>
         <p:nvSpPr>
@@ -31171,7 +31615,7 @@
                 <a:ea typeface="Noto Sans KR"/>
                 <a:cs typeface="Noto Sans KR"/>
               </a:rPr>
-              <a:t>Pi 장비 연결, 서버 개발과 기록 저장</a:t>
+              <a:t>노트북 장비 연결, 서버 개발과 기록 저장</a:t>
             </a:r>
             <a:endParaRPr sz="1100"/>
           </a:p>
@@ -31207,6 +31651,10 @@
             <a:prstDash val="solid"/>
           </a:ln>
         </p:spPr>
+        <p:txBody xmlns:a="http://schemas.openxmlformats.org/drawingml/2006/main">
+          <a:bodyPr/>
+          <a:p/>
+        </p:txBody>
       </p:sp>
       <p:sp>
         <p:nvSpPr>
@@ -31288,6 +31736,10 @@
             <a:prstDash val="solid"/>
           </a:ln>
         </p:spPr>
+        <p:txBody xmlns:a="http://schemas.openxmlformats.org/drawingml/2006/main">
+          <a:bodyPr/>
+          <a:p/>
+        </p:txBody>
       </p:sp>
       <p:sp>
         <p:nvSpPr>
@@ -31432,6 +31884,10 @@
             <a:prstDash val="solid"/>
           </a:ln>
         </p:spPr>
+        <p:txBody xmlns:a="http://schemas.openxmlformats.org/drawingml/2006/main">
+          <a:bodyPr/>
+          <a:p/>
+        </p:txBody>
       </p:sp>
       <p:sp>
         <p:nvSpPr>
@@ -31513,6 +31969,10 @@
             <a:prstDash val="solid"/>
           </a:ln>
         </p:spPr>
+        <p:txBody xmlns:a="http://schemas.openxmlformats.org/drawingml/2006/main">
+          <a:bodyPr/>
+          <a:p/>
+        </p:txBody>
       </p:sp>
       <p:sp>
         <p:nvSpPr>
@@ -31661,6 +32121,10 @@
             <a:prstDash val="solid"/>
           </a:ln>
         </p:spPr>
+        <p:txBody xmlns:a="http://schemas.openxmlformats.org/drawingml/2006/main">
+          <a:bodyPr/>
+          <a:p/>
+        </p:txBody>
       </p:sp>
       <p:sp>
         <p:nvSpPr>
@@ -31857,6 +32321,10 @@
             <a:prstDash val="solid"/>
           </a:ln>
         </p:spPr>
+        <p:txBody xmlns:a="http://schemas.openxmlformats.org/drawingml/2006/main">
+          <a:bodyPr/>
+          <a:p/>
+        </p:txBody>
       </p:sp>
       <p:sp>
         <p:nvSpPr>
@@ -32285,7 +32753,7 @@
                 <a:ea typeface="Noto Sans KR"/>
                 <a:cs typeface="Noto Sans KR"/>
               </a:rPr>
-              <a:t>Raspberry Pi   소리와 영상을 녹음·촬영하고 PC로 전달</a:t>
+              <a:t>수집 프로그램   노트북 마이크·웹캠으로 소리와 영상을 녹음·촬영</a:t>
             </a:r>
           </a:p>
         </p:txBody>
@@ -32560,6 +33028,10 @@
             <a:prstDash val="solid"/>
           </a:ln>
         </p:spPr>
+        <p:txBody xmlns:a="http://schemas.openxmlformats.org/drawingml/2006/main">
+          <a:bodyPr/>
+          <a:p/>
+        </p:txBody>
       </p:sp>
       <p:sp>
         <p:nvSpPr>
@@ -33278,7 +33750,7 @@
                           <a:ea typeface="Noto Sans KR"/>
                           <a:cs typeface="Noto Sans KR"/>
                         </a:rPr>
-                        <a:t>Pi가 소리와 영상을 짧게 나눠 수집</a:t>
+                        <a:t>수집 프로그램이 소리와 영상을 짧게 나눠 수집</a:t>
                       </a:r>
                     </a:p>
                   </a:txBody>
@@ -33809,6 +34281,10 @@
             <a:prstDash val="solid"/>
           </a:ln>
         </p:spPr>
+        <p:txBody xmlns:a="http://schemas.openxmlformats.org/drawingml/2006/main">
+          <a:bodyPr/>
+          <a:p/>
+        </p:txBody>
       </p:sp>
       <p:sp>
         <p:nvSpPr>
@@ -34118,6 +34594,10 @@
             <a:prstDash val="solid"/>
           </a:ln>
         </p:spPr>
+        <p:txBody xmlns:a="http://schemas.openxmlformats.org/drawingml/2006/main">
+          <a:bodyPr/>
+          <a:p/>
+        </p:txBody>
       </p:sp>
       <p:sp>
         <p:nvSpPr>
@@ -34354,6 +34834,10 @@
             <a:prstDash val="solid"/>
           </a:ln>
         </p:spPr>
+        <p:txBody xmlns:a="http://schemas.openxmlformats.org/drawingml/2006/main">
+          <a:bodyPr/>
+          <a:p/>
+        </p:txBody>
       </p:sp>
       <p:sp>
         <p:nvSpPr>
@@ -34463,6 +34947,10 @@
             </a:outerShdw>
           </a:effectLst>
         </p:spPr>
+        <p:txBody xmlns:a="http://schemas.openxmlformats.org/drawingml/2006/main">
+          <a:bodyPr/>
+          <a:p/>
+        </p:txBody>
       </p:sp>
       <p:sp>
         <p:nvSpPr>
@@ -34563,6 +35051,10 @@
             <a:prstDash val="solid"/>
           </a:ln>
         </p:spPr>
+        <p:txBody xmlns:a="http://schemas.openxmlformats.org/drawingml/2006/main">
+          <a:bodyPr/>
+          <a:p/>
+        </p:txBody>
       </p:sp>
       <p:sp>
         <p:nvSpPr>
@@ -34674,6 +35166,10 @@
             <a:prstDash val="solid"/>
           </a:ln>
         </p:spPr>
+        <p:txBody xmlns:a="http://schemas.openxmlformats.org/drawingml/2006/main">
+          <a:bodyPr/>
+          <a:p/>
+        </p:txBody>
       </p:sp>
       <p:sp>
         <p:nvSpPr>
@@ -34785,6 +35281,10 @@
             <a:prstDash val="solid"/>
           </a:ln>
         </p:spPr>
+        <p:txBody xmlns:a="http://schemas.openxmlformats.org/drawingml/2006/main">
+          <a:bodyPr/>
+          <a:p/>
+        </p:txBody>
       </p:sp>
       <p:sp>
         <p:nvSpPr>
@@ -34896,6 +35396,10 @@
             <a:prstDash val="solid"/>
           </a:ln>
         </p:spPr>
+        <p:txBody xmlns:a="http://schemas.openxmlformats.org/drawingml/2006/main">
+          <a:bodyPr/>
+          <a:p/>
+        </p:txBody>
       </p:sp>
       <p:sp>
         <p:nvSpPr>
@@ -35009,6 +35513,10 @@
             <a:prstDash val="solid"/>
           </a:ln>
         </p:spPr>
+        <p:txBody xmlns:a="http://schemas.openxmlformats.org/drawingml/2006/main">
+          <a:bodyPr/>
+          <a:p/>
+        </p:txBody>
       </p:sp>
       <p:sp>
         <p:nvSpPr>
@@ -35044,6 +35552,10 @@
             <a:prstDash val="solid"/>
           </a:ln>
         </p:spPr>
+        <p:txBody xmlns:a="http://schemas.openxmlformats.org/drawingml/2006/main">
+          <a:bodyPr/>
+          <a:p/>
+        </p:txBody>
       </p:sp>
       <p:sp>
         <p:nvSpPr>
@@ -35192,6 +35704,10 @@
             <a:prstDash val="solid"/>
           </a:ln>
         </p:spPr>
+        <p:txBody xmlns:a="http://schemas.openxmlformats.org/drawingml/2006/main">
+          <a:bodyPr/>
+          <a:p/>
+        </p:txBody>
       </p:sp>
       <p:sp>
         <p:nvSpPr>
@@ -35227,6 +35743,10 @@
             <a:prstDash val="solid"/>
           </a:ln>
         </p:spPr>
+        <p:txBody xmlns:a="http://schemas.openxmlformats.org/drawingml/2006/main">
+          <a:bodyPr/>
+          <a:p/>
+        </p:txBody>
       </p:sp>
       <p:sp>
         <p:nvSpPr>
@@ -35375,6 +35895,10 @@
             <a:prstDash val="solid"/>
           </a:ln>
         </p:spPr>
+        <p:txBody xmlns:a="http://schemas.openxmlformats.org/drawingml/2006/main">
+          <a:bodyPr/>
+          <a:p/>
+        </p:txBody>
       </p:sp>
       <p:sp>
         <p:nvSpPr>
@@ -35410,6 +35934,10 @@
             <a:prstDash val="solid"/>
           </a:ln>
         </p:spPr>
+        <p:txBody xmlns:a="http://schemas.openxmlformats.org/drawingml/2006/main">
+          <a:bodyPr/>
+          <a:p/>
+        </p:txBody>
       </p:sp>
       <p:sp>
         <p:nvSpPr>

</xml_diff>